<commit_message>
docs(presentation): revise slides and PDF to student-friendly presentation with natural speaking lines
</commit_message>
<xml_diff>
--- a/demo/slides.pptx
+++ b/demo/slides.pptx
@@ -511,7 +511,7 @@
           <a:lstStyle/>
           <a:p>
             <a:r>
-              <a:t>Good morning, evaluators. Welcome to my DevSecOps Capstone presentation on PodiumHQ. Rather than cloning a generic TaskBoard, PodiumHQ addresses the operational challenge of running large-scale hackathons and technical project evaluations. In this presentation, I will walk you through the entire cloud-native lifecycle: from our 91% coverage backend and hardened non-root containers, to our GitHub Actions CI/CD with Trivy gates, Terraform AWS infrastructure, ArgoCD GitOps, and Prometheus observability.</a:t>
+              <a:t>Hi everyone. My name is [Your Name], and today I am presenting my DevSecOps capstone project, PodiumHQ. During college hackathons, I noticed organizers always struggle with messy spreadsheets and calculating weighted scores under tight deadlines. I built PodiumHQ to solve this: it is a web platform where judges submit scores against specific criteria and the leaderboard updates live. More importantly, I used this project to learn and implement a complete DevSecOps pipeline, including automated testing, non-root containers, CI/CD scanning, Terraform, Kubernetes, and monitoring.</a:t>
             </a:r>
           </a:p>
         </p:txBody>
@@ -581,7 +581,7 @@
           <a:lstStyle/>
           <a:p>
             <a:r>
-              <a:t>To conclude on Slide 10: PodiumHQ successfully satisfies the 100-point Capstone Grading Rubric. Through this project, we demonstrated that modern DevSecOps is about defense-in-depth: from unit testing and non-root container isolation, to immutable GitOps synchronization and declarative cloud infrastructure. All evidence logs, runbooks, and presentation materials are committed to the repository. Thank you for your attention, and I am now ready for your questions.</a:t>
+              <a:t>To conclude on Slide 10: PodiumHQ successfully demonstrates a modern DevSecOps project from scratch. Locally, everything is verified green: 31 tests pass with 91% coverage, all containers run healthy as non-root users, and all manifests for Terraform, Helm, ArgoCD, and Grafana are complete and validated. To be transparent about limitations: because cloud EKS and NAT Gateways incur hourly AWS bills, the cloud deployment was kept as validated code rather than a running cluster. This project gave me hands-on experience solving real configuration, security, and deployment challenges. Thank you, and I look forward to your questions!</a:t>
             </a:r>
           </a:p>
         </p:txBody>
@@ -651,7 +651,7 @@
           <a:lstStyle/>
           <a:p>
             <a:r>
-              <a:t>On Slide 2, we break down the application architecture across three distinct tiers. Our frontend is built with React 18 and Vite, packaged in an unprivileged Nginx container running as UID 101. Our backend is powered by FastAPI and Python 3.12, providing high-throughput async REST endpoints. All data is persisted in PostgreSQL 16 using SQLAlchemy 2.0 and Alembic migrations. Crucially, both containers run as unprivileged, non-root users verified inside the runtime.</a:t>
+              <a:t>On Slide 2, here is how the application is built. For the frontend, I chose React 18 with Vite and Tailwind CSS so the scoring page and leaderboard update smoothly without refreshing. For the backend, I used FastAPI with Python 3.12 because it is asynchronous, validates incoming requests with Pydantic schemas, and automatically generates interactive API documentation at /docs. For storage, I used PostgreSQL 16 with SQLAlchemy and Alembic migrations to keep our data consistent. Both backend and frontend containers run as non-root users for basic security hygiene.</a:t>
             </a:r>
           </a:p>
         </p:txBody>
@@ -721,7 +721,7 @@
           <a:lstStyle/>
           <a:p>
             <a:r>
-              <a:t>Slide 3 presents our end-to-end architecture diagram. Every commit travels a strictly validated pipeline: developer commits trigger GitHub Actions, which runs static checks, enforces our 91% pytest coverage, builds multi-stage images, and scans with Trivy. Images are published to GHCR with immutable Git SHA tags. ArgoCD continuously reconciles this repository with our AWS EKS cluster, where traffic passes through an Ingress controller to replicated pods autoscaled by HPA, all while Prometheus scrapes live telemetry.</a:t>
+              <a:t>This diagram on Slide 3 shows the overall architecture. When I push code to GitHub, GitHub Actions runs our automated pipeline: linting, running 31 pytest tests, building the Docker containers, and scanning them with Trivy. If everything passes, the image is tagged with the Git commit hash and pushed to GitHub Container Registry. From there, ArgoCD pulls the update into Kubernetes. An Ingress controller sends user traffic to our frontend, API calls to our backend pods, and Prometheus continuously monitors the whole system.</a:t>
             </a:r>
           </a:p>
         </p:txBody>
@@ -791,7 +791,7 @@
           <a:lstStyle/>
           <a:p>
             <a:r>
-              <a:t>On Slide 4, we examine our CI/CD implementation defined in .github/workflows/ci-cd.yml. The pipeline enforces three sequential quality gates. First, Ruff and Mypy perform automated static analysis. Second, Pytest executes 31 tests and verifies our coverage threshold. Third, Docker Buildx compiles our multi-stage images, followed by Trivy vulnerability scanning. If any high or critical vulnerability is found, the build fails and nothing is pushed to GitHub Container Registry.</a:t>
+              <a:t>Slide 4 covers our CI/CD pipeline, configured in .github/workflows/ci-cd.yml. I divided it into three clear gates. First, Ruff and Mypy check code formatting and type safety. Second, Pytest runs all 31 tests and checks code coverage. We enforce an 80% threshold, and our tests currently hit 91%. If any test fails or coverage drops, the pipeline stops immediately. Third, we build the Docker images and run Trivy to scan for security vulnerabilities. Only clean images get tagged with the Git commit SHA and pushed to the container registry.</a:t>
             </a:r>
           </a:p>
         </p:txBody>
@@ -861,7 +861,7 @@
           <a:lstStyle/>
           <a:p>
             <a:r>
-              <a:t>Slide 5 covers our Infrastructure as Code implemented in the terraform/ directory. We provision a resilient AWS VPC across 3 Availability Zones with private subnets for EKS worker nodes and public subnets for ingress. The cluster runs Kubernetes 1.30 with an autoscaling managed node group. We explicitly deploy the AWS EBS CSI driver and Metrics Server as Terraform add-ons, which are mandatory for our database persistence and pod autoscaling. A comprehensive destroy runbook is provided to ensure zero cloud cost leakage.</a:t>
+              <a:t>On Slide 5, we look at our cloud infrastructure defined in the terraform/ directory. Instead of clicking around the AWS console, I wrote Terraform code to create an AWS VPC across 3 Availability Zones, with private subnets for security and public subnets for ingress. The EKS configuration provisions a Kubernetes 1.30 cluster with 2 to 4 worker nodes. I also added two essential EKS add-ons: the EBS CSI driver for database storage, and the Metrics Server for pod autoscaling. Because AWS EKS costs real money every hour, the code is fully validated, and I included a teardown runbook to destroy resources safely.</a:t>
             </a:r>
           </a:p>
         </p:txBody>
@@ -931,7 +931,7 @@
           <a:lstStyle/>
           <a:p>
             <a:r>
-              <a:t>Slide 6 details our Kubernetes packaging in helm/podiumhq. Our backend and frontend run with at least 2 replicas each, protected by PodDisruptionBudgets and RollingUpdate strategies. All pods enforce strict non-root SecurityContexts and drop all Linux capabilities. To solve the common production pitfall where multiple replicas race during database migrations, we implemented a Helm pre-install and pre-upgrade Job hook that executes Alembic migrations before the application pods boot.</a:t>
+              <a:t>On Slide 6, we look at how the application is packaged for Kubernetes using Helm. Both backend and frontend are configured with 2 replicas each, protected by a PodDisruptionBudget and autoscaled by HPA. In Kubernetes, security is critical, so our pod manifests strictly enforce non-root execution and drop all Linux capabilities. One practical problem I solved was database migration race conditions: if two backend pods start at once, they clash over database schema locks. I resolved this by turning migrations into a Helm pre-install and pre-upgrade Job hook that finishes completely before any application pods boot.</a:t>
             </a:r>
           </a:p>
         </p:txBody>
@@ -1001,7 +1001,7 @@
           <a:lstStyle/>
           <a:p>
             <a:r>
-              <a:t>On Slide 7, we present GitOps continuous delivery powered by ArgoCD. In argocd/application.yaml, ArgoCD monitors our repository and uses values-prod.yaml to deploy the application. With automated sync, self-healing, and pruning enabled, Git is the single source of truth. During evaluation, we demonstrate self-healing by manually scaling the backend via kubectl; ArgoCD immediately detects the configuration drift and reconciles the cluster back to the expected state.</a:t>
+              <a:t>Slide 7 introduces GitOps using ArgoCD. Instead of manually deploying code with kubectl commands from a terminal, GitOps makes our Git repository the single source of truth. ArgoCD runs in the cluster and monitors our Helm chart. When our CI pipeline updates an image tag, ArgoCD automatically synchronizes the cluster. It also has self-healing enabled: if someone manually modifies a pod count or setting in the cluster, ArgoCD detects the drift and immediately restores the cluster back to what is defined in Git.</a:t>
             </a:r>
           </a:p>
         </p:txBody>
@@ -1071,7 +1071,7 @@
           <a:lstStyle/>
           <a:p>
             <a:r>
-              <a:t>Slide 8 covers our observability stack. Under /metrics, we expose standard HTTP metrics alongside three custom domain metrics: scores submitted, team lifecycle status counts, and leaderboard requests. Our pre-provisioned Grafana dashboard in monitoring/grafana-dashboard.json visualizes throughput, p95 latencies, and business activity. We also include PrometheusRule alerts that trigger notifications if the backend goes down or if 5xx errors exceed 1%.</a:t>
+              <a:t>On Slide 8, we look at observability. Under /metrics, our backend exposes standard Prometheus telemetry, including HTTP request rates and p95 latency histograms. To make monitoring genuinely useful for this hackathon platform, I also implemented three custom domain metrics: scores submitted, team status counts, and leaderboard views. We packaged a pre-built Grafana dashboard in the monitoring/ directory to visualize these numbers, along with Prometheus alert rules that warn us if error rates spike or if a service goes down.</a:t>
             </a:r>
           </a:p>
         </p:txBody>
@@ -1141,7 +1141,7 @@
           <a:lstStyle/>
           <a:p>
             <a:r>
-              <a:t>Slide 9 highlights our quality assurance and the real engineering obstacles we resolved. We verified our test suite: 31 tests pass with 91% code coverage, and our containers were verified as non-root UIDs 10001 and 101. We also solved authentic production issues: first, fixing in-container coverage file permissions by explicitly chowning the working directory; second, resolving an IPv6 dual-stack mismatch in Alpine Linux Nginx healthchecks; and third, ensuring test fixtures were appropriately packaged into the container.</a:t>
+              <a:t>Slide 9 highlights our testing and some real debugging problems I ran into and solved. Our test suite has 31 automated tests with 91% code coverage, and our containers were verified as non-root users. During development, I hit two interesting bugs. First, pytest kept crashing inside the container because the /app folder was owned by root, preventing our non-root user from writing the coverage database. I fixed this by chowning the directory in the Dockerfile. Second, Docker marked the frontend container unhealthy because BusyBox wget tried connecting to IPv6 localhost while Nginx only listened on IPv4. Adding an IPv6 listen directive solved the issue.</a:t>
             </a:r>
           </a:p>
         </p:txBody>
@@ -4268,7 +4268,7 @@
               </a:defRPr>
             </a:pPr>
             <a:r>
-              <a:t>MODULE CHECKPOINT • PROJECT OVERVIEW &amp; IDENTITY</a:t>
+              <a:t>STUDENT PRESENTATION • PROJECT INTRODUCTION</a:t>
             </a:r>
           </a:p>
         </p:txBody>
@@ -4340,7 +4340,7 @@
               </a:defRPr>
             </a:pPr>
             <a:r>
-              <a:t>PodiumHQ — DevSecOps Capstone</a:t>
+              <a:t>PodiumHQ — Hackathon Scoring Platform</a:t>
             </a:r>
           </a:p>
         </p:txBody>
@@ -4376,7 +4376,7 @@
               </a:defRPr>
             </a:pPr>
             <a:r>
-              <a:t>Autonomous Hackathon &amp; Event Judging Platform with Hardened GitOps Delivery</a:t>
+              <a:t>DevSecOps Capstone Project | Final Year Technical Presentation</a:t>
             </a:r>
           </a:p>
         </p:txBody>
@@ -4457,7 +4457,7 @@
               </a:defRPr>
             </a:pPr>
             <a:r>
-              <a:t>Core Problem Solved</a:t>
+              <a:t>What is PodiumHQ?</a:t>
             </a:r>
           </a:p>
         </p:txBody>
@@ -4496,7 +4496,7 @@
               </a:defRPr>
             </a:pPr>
             <a:r>
-              <a:t>• Replaces error-prone manual spreadsheets with an automated multi-criteria evaluation platform.</a:t>
+              <a:t>• A full-stack web platform for organizing and judging hackathons.</a:t>
             </a:r>
           </a:p>
           <a:p>
@@ -4512,7 +4512,7 @@
               </a:defRPr>
             </a:pPr>
             <a:r>
-              <a:t>• Provides real-time weighted scoring across rounds with dynamic tie-breaking and rank calculation.</a:t>
+              <a:t>• Allows judges to evaluate teams across multiple rounds and weighted criteria.</a:t>
             </a:r>
           </a:p>
           <a:p>
@@ -4528,7 +4528,7 @@
               </a:defRPr>
             </a:pPr>
             <a:r>
-              <a:t>• Engineered specifically to solve high-concurrency judging deadlines with zero downtime.</a:t>
+              <a:t>• Computes team rankings in real time and displays an automated live leaderboard.</a:t>
             </a:r>
           </a:p>
         </p:txBody>
@@ -4609,7 +4609,7 @@
               </a:defRPr>
             </a:pPr>
             <a:r>
-              <a:t>DevSecOps Mission &amp; Scope</a:t>
+              <a:t>Why I Built This (Problem &amp; Goal)</a:t>
             </a:r>
           </a:p>
         </p:txBody>
@@ -4648,7 +4648,7 @@
               </a:defRPr>
             </a:pPr>
             <a:r>
-              <a:t>• Demonstrates the full software delivery journey from local commit to cloud-native production.</a:t>
+              <a:t>• Solves the mess of manual spreadsheets and delayed scores during hackathon deadlines.</a:t>
             </a:r>
           </a:p>
           <a:p>
@@ -4664,7 +4664,7 @@
               </a:defRPr>
             </a:pPr>
             <a:r>
-              <a:t>• Enforces security gates: non-root containers, Trivy CVE scanning, and Gitleaks detection.</a:t>
+              <a:t>• Original application domain—built from scratch with zero TaskBoard code reuse.</a:t>
             </a:r>
           </a:p>
           <a:p>
@@ -4680,7 +4680,7 @@
               </a:defRPr>
             </a:pPr>
             <a:r>
-              <a:t>• Delivers declarative GitOps via ArgoCD, Helm 3 packaging, and Terraform-provisioned AWS EKS.</a:t>
+              <a:t>• Goal: Take a real web app through the complete DevSecOps pipeline from commit to cloud.</a:t>
             </a:r>
           </a:p>
         </p:txBody>
@@ -4761,7 +4761,7 @@
               </a:defRPr>
             </a:pPr>
             <a:r>
-              <a:t>Project Metadata</a:t>
+              <a:t>Student &amp; Project Info</a:t>
             </a:r>
           </a:p>
         </p:txBody>
@@ -4800,7 +4800,7 @@
               </a:defRPr>
             </a:pPr>
             <a:r>
-              <a:t>• Author: Platform Engineering / DevSecOps Candidate</a:t>
+              <a:t>• Student Name: [Your Name]</a:t>
             </a:r>
           </a:p>
           <a:p>
@@ -4816,7 +4816,7 @@
               </a:defRPr>
             </a:pPr>
             <a:r>
-              <a:t>• Domain: Hackathon &amp; Event Evaluation (Original Domain, Zero TaskBoard Overlap)</a:t>
+              <a:t>• Course / Degree: B.Tech / B.E. Computer Science &amp; Engineering</a:t>
             </a:r>
           </a:p>
           <a:p>
@@ -4832,7 +4832,7 @@
               </a:defRPr>
             </a:pPr>
             <a:r>
-              <a:t>• Rubric Target: 100/100 Points across Modules M1 through M10</a:t>
+              <a:t>• Stack: React 18, FastAPI, PostgreSQL, Docker, GitHub Actions, Terraform, Kubernetes</a:t>
             </a:r>
           </a:p>
         </p:txBody>
@@ -4868,7 +4868,7 @@
               </a:defRPr>
             </a:pPr>
             <a:r>
-              <a:t>PodiumHQ DevSecOps Capstone • GitOps, Automated Verification &amp; Observability</a:t>
+              <a:t>PodiumHQ DevSecOps Capstone Presentation • Verified Codebase &amp; Realistic Engineering</a:t>
             </a:r>
           </a:p>
         </p:txBody>
@@ -5012,7 +5012,7 @@
               </a:defRPr>
             </a:pPr>
             <a:r>
-              <a:t>MODULE CHECKPOINT • CONCLUSION &amp; ROADMAP</a:t>
+              <a:t>STUDENT PRESENTATION • CONCLUSION &amp; LEARNINGS</a:t>
             </a:r>
           </a:p>
         </p:txBody>
@@ -5084,7 +5084,7 @@
               </a:defRPr>
             </a:pPr>
             <a:r>
-              <a:t>Key Learnings &amp; Conclusion</a:t>
+              <a:t>Summary, Limitations &amp; Key Learnings</a:t>
             </a:r>
           </a:p>
         </p:txBody>
@@ -5120,7 +5120,7 @@
               </a:defRPr>
             </a:pPr>
             <a:r>
-              <a:t>100-Point Rubric Fulfillment, Production Takeaways, and Future Roadmap</a:t>
+              <a:t>Honest self-assessment of achievements, cloud limitations, and future improvements</a:t>
             </a:r>
           </a:p>
         </p:txBody>
@@ -5201,7 +5201,7 @@
               </a:defRPr>
             </a:pPr>
             <a:r>
-              <a:t>Rubric Self-Audit (RUBRIC_CHECK.md)</a:t>
+              <a:t>What Works &amp; Was Verified</a:t>
             </a:r>
           </a:p>
         </p:txBody>
@@ -5240,7 +5240,7 @@
               </a:defRPr>
             </a:pPr>
             <a:r>
-              <a:t>• 100% compliance across all 10 modules (M1 Application to M10 Presentation).</a:t>
+              <a:t>• Fully functional hackathon scoring platform running locally on Docker Compose.</a:t>
             </a:r>
           </a:p>
           <a:p>
@@ -5256,7 +5256,7 @@
               </a:defRPr>
             </a:pPr>
             <a:r>
-              <a:t>• Locally runnable components (Docker Compose, Pytest 91%, Non-Root, Probes) are 100% verified green.</a:t>
+              <a:t>• 31 automated tests passing with 90.99% coverage and isolated test fixtures.</a:t>
             </a:r>
           </a:p>
           <a:p>
@@ -5272,7 +5272,23 @@
               </a:defRPr>
             </a:pPr>
             <a:r>
-              <a:t>• Cloud-only components (AWS EKS apply, live ArgoCD) are fully written, validated, and documented.</a:t>
+              <a:t>• Non-root container execution verified live on both backend and frontend.</a:t>
+            </a:r>
+          </a:p>
+          <a:p>
+            <a:pPr>
+              <a:spcAft>
+                <a:spcPts val="800"/>
+              </a:spcAft>
+              <a:defRPr sz="1200">
+                <a:solidFill>
+                  <a:srgbClr val="F8FAFC"/>
+                </a:solidFill>
+                <a:latin typeface="Calibri"/>
+              </a:defRPr>
+            </a:pPr>
+            <a:r>
+              <a:t>• Complete, validated manifest suite: Terraform, Helm chart, ArgoCD, and Prometheus.</a:t>
             </a:r>
           </a:p>
         </p:txBody>
@@ -5347,13 +5363,13 @@
             <a:pPr>
               <a:defRPr sz="1400" b="1">
                 <a:solidFill>
-                  <a:srgbClr val="38BDF8"/>
+                  <a:srgbClr val="F59E0B"/>
                 </a:solidFill>
                 <a:latin typeface="Arial"/>
               </a:defRPr>
             </a:pPr>
             <a:r>
-              <a:t>Key Engineering Lessons</a:t>
+              <a:t>Honest Limitations (Cloud Scope)</a:t>
             </a:r>
           </a:p>
         </p:txBody>
@@ -5392,7 +5408,7 @@
               </a:defRPr>
             </a:pPr>
             <a:r>
-              <a:t>• Pre-upgrade Helm hooks are essential to avoid database schema race conditions across replicated pods.</a:t>
+              <a:t>• AWS EKS &amp; ArgoCD were not deployed to live cloud infrastructure to avoid ongoing student cloud costs.</a:t>
             </a:r>
           </a:p>
           <a:p>
@@ -5408,7 +5424,7 @@
               </a:defRPr>
             </a:pPr>
             <a:r>
-              <a:t>• Dual-stack IPv4/IPv6 awareness is critical when containerizing unprivileged Nginx on modern Alpine Linux.</a:t>
+              <a:t>• All cloud manifests are written, syntactically validated, and ready for deployment.</a:t>
             </a:r>
           </a:p>
           <a:p>
@@ -5424,7 +5440,7 @@
               </a:defRPr>
             </a:pPr>
             <a:r>
-              <a:t>• Immutable image tagging by Git commit SHA ensures reliable GitOps rollback without caching ambiguities.</a:t>
+              <a:t>• Everything runnable locally was verified 100% green with saved evidence files.</a:t>
             </a:r>
           </a:p>
         </p:txBody>
@@ -5499,13 +5515,13 @@
             <a:pPr>
               <a:defRPr sz="1400" b="1">
                 <a:solidFill>
-                  <a:srgbClr val="F59E0B"/>
+                  <a:srgbClr val="38BDF8"/>
                 </a:solidFill>
                 <a:latin typeface="Arial"/>
               </a:defRPr>
             </a:pPr>
             <a:r>
-              <a:t>Future Production Enhancements</a:t>
+              <a:t>Top Engineering Lessons</a:t>
             </a:r>
           </a:p>
         </p:txBody>
@@ -5544,7 +5560,7 @@
               </a:defRPr>
             </a:pPr>
             <a:r>
-              <a:t>• Transition in-cluster PostgreSQL to Amazon Aurora Multi-AZ with automated automated failover.</a:t>
+              <a:t>• DevSecOps is in the details: file permissions, non-root users, and dual-stack networking.</a:t>
             </a:r>
           </a:p>
           <a:p>
@@ -5560,7 +5576,7 @@
               </a:defRPr>
             </a:pPr>
             <a:r>
-              <a:t>• Implement OpenTelemetry distributed tracing with AWS X-Ray for end-to-end request tracing.</a:t>
+              <a:t>• Helm pre-upgrade hooks are crucial to prevent database migration locks across replicas.</a:t>
             </a:r>
           </a:p>
           <a:p>
@@ -5576,7 +5592,7 @@
               </a:defRPr>
             </a:pPr>
             <a:r>
-              <a:t>• Deploy Istio Service Mesh with mTLS and fine-grained authorization policies across microservices.</a:t>
+              <a:t>• Immutable image tags (Git commit SHAs) prevent deployment caching confusion.</a:t>
             </a:r>
           </a:p>
         </p:txBody>
@@ -5612,7 +5628,7 @@
               </a:defRPr>
             </a:pPr>
             <a:r>
-              <a:t>PodiumHQ DevSecOps Capstone • GitOps, Automated Verification &amp; Observability</a:t>
+              <a:t>PodiumHQ DevSecOps Capstone Presentation • Verified Codebase &amp; Realistic Engineering</a:t>
             </a:r>
           </a:p>
         </p:txBody>
@@ -5756,7 +5772,7 @@
               </a:defRPr>
             </a:pPr>
             <a:r>
-              <a:t>MODULE CHECKPOINT • TECH STACK SPECIFICATION</a:t>
+              <a:t>STUDENT PRESENTATION • TECH STACK</a:t>
             </a:r>
           </a:p>
         </p:txBody>
@@ -5828,7 +5844,7 @@
               </a:defRPr>
             </a:pPr>
             <a:r>
-              <a:t>Application &amp; Technology Stack</a:t>
+              <a:t>Application Stack &amp; Why I Chose These Tools</a:t>
             </a:r>
           </a:p>
         </p:txBody>
@@ -5864,7 +5880,7 @@
               </a:defRPr>
             </a:pPr>
             <a:r>
-              <a:t>High-Performance Modern Web Architecture with Relational Integrity</a:t>
+              <a:t>Simple, clean 3-tier architecture built with modern open-source tools</a:t>
             </a:r>
           </a:p>
         </p:txBody>
@@ -5945,7 +5961,7 @@
               </a:defRPr>
             </a:pPr>
             <a:r>
-              <a:t>Frontend Tier (React 18 SPA)</a:t>
+              <a:t>Frontend: React 18 + Vite</a:t>
             </a:r>
           </a:p>
         </p:txBody>
@@ -5984,7 +6000,7 @@
               </a:defRPr>
             </a:pPr>
             <a:r>
-              <a:t>• React 18 + Vite with Tailwind CSS styling in an Obsidian &amp; Solar Gold palette.</a:t>
+              <a:t>• What it does: Single-page application with Tailwind CSS in an Obsidian &amp; Solar Gold theme.</a:t>
             </a:r>
           </a:p>
           <a:p>
@@ -6000,7 +6016,7 @@
               </a:defRPr>
             </a:pPr>
             <a:r>
-              <a:t>• Live leaderboard with instantaneous client-side ranking and category filtering.</a:t>
+              <a:t>• Why I chose it: Needed a fast, reactive UI where judges can submit scores without page refreshes.</a:t>
             </a:r>
           </a:p>
           <a:p>
@@ -6016,23 +6032,7 @@
               </a:defRPr>
             </a:pPr>
             <a:r>
-              <a:t>• Responsive judge scoring form with client-side bounds and schema validation.</a:t>
-            </a:r>
-          </a:p>
-          <a:p>
-            <a:pPr>
-              <a:spcAft>
-                <a:spcPts val="800"/>
-              </a:spcAft>
-              <a:defRPr sz="1200">
-                <a:solidFill>
-                  <a:srgbClr val="F8FAFC"/>
-                </a:solidFill>
-                <a:latin typeface="Calibri"/>
-              </a:defRPr>
-            </a:pPr>
-            <a:r>
-              <a:t>• Runtime: Served via unprivileged Nginx (UID 101) with dynamic proxying to backend.</a:t>
+              <a:t>• Runtime: Served through unprivileged Nginx on port 8080 (running as UID 101).</a:t>
             </a:r>
           </a:p>
         </p:txBody>
@@ -6113,7 +6113,7 @@
               </a:defRPr>
             </a:pPr>
             <a:r>
-              <a:t>Backend Tier (FastAPI Async API)</a:t>
+              <a:t>Backend: FastAPI (Python 3.12)</a:t>
             </a:r>
           </a:p>
         </p:txBody>
@@ -6152,7 +6152,7 @@
               </a:defRPr>
             </a:pPr>
             <a:r>
-              <a:t>• Python 3.12 running asynchronous FastAPI ASGI server with Uvicorn.</a:t>
+              <a:t>• What it does: Handles 15+ REST endpoints for teams, criteria, judges, and score calculations.</a:t>
             </a:r>
           </a:p>
           <a:p>
@@ -6168,23 +6168,7 @@
               </a:defRPr>
             </a:pPr>
             <a:r>
-              <a:t>• 15+ RESTful endpoints under /api/events, /api/teams, /api/judges, /api/scores, and /api/leaderboard.</a:t>
-            </a:r>
-          </a:p>
-          <a:p>
-            <a:pPr>
-              <a:spcAft>
-                <a:spcPts val="800"/>
-              </a:spcAft>
-              <a:defRPr sz="1200">
-                <a:solidFill>
-                  <a:srgbClr val="F8FAFC"/>
-                </a:solidFill>
-                <a:latin typeface="Calibri"/>
-              </a:defRPr>
-            </a:pPr>
-            <a:r>
-              <a:t>• Operational probes: /health (liveness), /ready (database ping), and /metrics (Prometheus).</a:t>
+              <a:t>• Why I chose it: Automatic Swagger docs at /docs, async performance, and built-in health probes.</a:t>
             </a:r>
           </a:p>
           <a:p>
@@ -6281,7 +6265,7 @@
               </a:defRPr>
             </a:pPr>
             <a:r>
-              <a:t>Data &amp; Persistence Tier (PostgreSQL 16)</a:t>
+              <a:t>Database: PostgreSQL 16</a:t>
             </a:r>
           </a:p>
         </p:txBody>
@@ -6320,7 +6304,7 @@
               </a:defRPr>
             </a:pPr>
             <a:r>
-              <a:t>• PostgreSQL 16 relational database with Psycopg 3 connection pooling.</a:t>
+              <a:t>• What it does: Stores events, rounds, criteria, teams, judges, and evaluations across 6 tables.</a:t>
             </a:r>
           </a:p>
           <a:p>
@@ -6336,7 +6320,7 @@
               </a:defRPr>
             </a:pPr>
             <a:r>
-              <a:t>• SQLAlchemy 2.0 ORM with relational foreign keys, unique constraints, and indexes.</a:t>
+              <a:t>• Why I chose it: Strong relational integrity, foreign keys, and safe schema migrations with Alembic.</a:t>
             </a:r>
           </a:p>
           <a:p>
@@ -6352,23 +6336,7 @@
               </a:defRPr>
             </a:pPr>
             <a:r>
-              <a:t>• Alembic schema migrations with automated pre-upgrade execution.</a:t>
-            </a:r>
-          </a:p>
-          <a:p>
-            <a:pPr>
-              <a:spcAft>
-                <a:spcPts val="800"/>
-              </a:spcAft>
-              <a:defRPr sz="1200">
-                <a:solidFill>
-                  <a:srgbClr val="F8FAFC"/>
-                </a:solidFill>
-                <a:latin typeface="Calibri"/>
-              </a:defRPr>
-            </a:pPr>
-            <a:r>
-              <a:t>• Cloud Storage: AWS EBS gp3 volume claim via AWS EBS CSI driver.</a:t>
+              <a:t>• Connection: Managed with SQLAlchemy 2.0 ORM and Psycopg 3 connection pooling.</a:t>
             </a:r>
           </a:p>
         </p:txBody>
@@ -6404,7 +6372,7 @@
               </a:defRPr>
             </a:pPr>
             <a:r>
-              <a:t>PodiumHQ DevSecOps Capstone • GitOps, Automated Verification &amp; Observability</a:t>
+              <a:t>PodiumHQ DevSecOps Capstone Presentation • Verified Codebase &amp; Realistic Engineering</a:t>
             </a:r>
           </a:p>
         </p:txBody>
@@ -6548,7 +6516,7 @@
               </a:defRPr>
             </a:pPr>
             <a:r>
-              <a:t>MODULE CHECKPOINT • SYSTEM ARCHITECTURE DIAGRAM</a:t>
+              <a:t>STUDENT PRESENTATION • SYSTEM ARCHITECTURE</a:t>
             </a:r>
           </a:p>
         </p:txBody>
@@ -6620,7 +6588,7 @@
               </a:defRPr>
             </a:pPr>
             <a:r>
-              <a:t>End-to-End System Architecture</a:t>
+              <a:t>System Architecture: From Code to Deployment</a:t>
             </a:r>
           </a:p>
         </p:txBody>
@@ -6656,7 +6624,7 @@
               </a:defRPr>
             </a:pPr>
             <a:r>
-              <a:t>Complete Flow: Developer -&gt; CI/CD -&gt; GitOps -&gt; AWS Cloud -&gt; Observability</a:t>
+              <a:t>How code moves from local development to automated deployment and monitoring</a:t>
             </a:r>
           </a:p>
         </p:txBody>
@@ -6792,7 +6760,7 @@
               </a:defRPr>
             </a:pPr>
             <a:r>
-              <a:t>Lint -&gt; Pytest 91% -&gt; Trivy</a:t>
+              <a:t>Lint -&gt; Tests -&gt; Scan</a:t>
             </a:r>
           </a:p>
         </p:txBody>
@@ -6996,7 +6964,7 @@
               </a:defRPr>
             </a:pPr>
             <a:r>
-              <a:t>VPC + Ingress + HPA</a:t>
+              <a:t>VPC + Pods + HPA</a:t>
             </a:r>
           </a:p>
         </p:txBody>
@@ -7145,7 +7113,7 @@
               </a:defRPr>
             </a:pPr>
             <a:r>
-              <a:t>Pipeline Flow (DevSecOps Quality Gates)</a:t>
+              <a:t>Delivery Flow (CI/CD to Registry)</a:t>
             </a:r>
           </a:p>
         </p:txBody>
@@ -7184,7 +7152,7 @@
               </a:defRPr>
             </a:pPr>
             <a:r>
-              <a:t>• Pre-commit verification enforces Ruff formatting and Gitleaks secret scanning.</a:t>
+              <a:t>• Developer pushes code to GitHub repository.</a:t>
             </a:r>
           </a:p>
           <a:p>
@@ -7200,7 +7168,7 @@
               </a:defRPr>
             </a:pPr>
             <a:r>
-              <a:t>• GitHub Actions executes automated gates: linting, pytest coverage (&gt;=80%), multi-stage builds.</a:t>
+              <a:t>• GitHub Actions automatically runs linters, 31 pytest tests, and builds container images.</a:t>
             </a:r>
           </a:p>
           <a:p>
@@ -7216,7 +7184,7 @@
               </a:defRPr>
             </a:pPr>
             <a:r>
-              <a:t>• Trivy blocks image publishing if any HIGH or CRITICAL CVEs are detected.</a:t>
+              <a:t>• Trivy scans images for security vulnerabilities before anything is published.</a:t>
             </a:r>
           </a:p>
           <a:p>
@@ -7232,7 +7200,7 @@
               </a:defRPr>
             </a:pPr>
             <a:r>
-              <a:t>• Approved container images are tagged with immutable Git commit SHAs—never :latest.</a:t>
+              <a:t>• Images are tagged with the Git commit SHA (e.g. :f990516) and pushed to GHCR.</a:t>
             </a:r>
           </a:p>
         </p:txBody>
@@ -7313,7 +7281,7 @@
               </a:defRPr>
             </a:pPr>
             <a:r>
-              <a:t>Cloud Runtime (AWS EKS &amp; GitOps Delivery)</a:t>
+              <a:t>Runtime Flow (Cluster &amp; Monitoring)</a:t>
             </a:r>
           </a:p>
         </p:txBody>
@@ -7352,7 +7320,7 @@
               </a:defRPr>
             </a:pPr>
             <a:r>
-              <a:t>• ArgoCD polls the repository, detects image updates, and auto-syncs manifests to the cluster.</a:t>
+              <a:t>• ArgoCD detects new image tags in Git and synchronizes manifests with the EKS cluster.</a:t>
             </a:r>
           </a:p>
           <a:p>
@@ -7368,7 +7336,7 @@
               </a:defRPr>
             </a:pPr>
             <a:r>
-              <a:t>• Traffic flows: AWS ALB / Ingress Controller -&gt; Frontend (:8080) -&gt; Backend (:8000) -&gt; PostgreSQL (:5432).</a:t>
+              <a:t>• Ingress routes incoming traffic: / to frontend pods and /api to backend pods.</a:t>
             </a:r>
           </a:p>
           <a:p>
@@ -7384,7 +7352,7 @@
               </a:defRPr>
             </a:pPr>
             <a:r>
-              <a:t>• Horizontal Pod Autoscaler (HPA) dynamically scales backend pods between 2 and 6 replicas based on CPU load.</a:t>
+              <a:t>• Horizontal Pod Autoscaler (HPA) scales backend pods between 2 and 6 replicas based on CPU.</a:t>
             </a:r>
           </a:p>
           <a:p>
@@ -7400,7 +7368,7 @@
               </a:defRPr>
             </a:pPr>
             <a:r>
-              <a:t>• Prometheus scrapes application metrics every 15s via dedicated ServiceMonitor.</a:t>
+              <a:t>• Prometheus continuously scrapes /metrics to track response times and error rates.</a:t>
             </a:r>
           </a:p>
         </p:txBody>
@@ -7436,7 +7404,7 @@
               </a:defRPr>
             </a:pPr>
             <a:r>
-              <a:t>PodiumHQ DevSecOps Capstone • GitOps, Automated Verification &amp; Observability</a:t>
+              <a:t>PodiumHQ DevSecOps Capstone Presentation • Verified Codebase &amp; Realistic Engineering</a:t>
             </a:r>
           </a:p>
         </p:txBody>
@@ -7580,7 +7548,7 @@
               </a:defRPr>
             </a:pPr>
             <a:r>
-              <a:t>MODULE CHECKPOINT • CONTINUOUS DELIVERY PIPELINE</a:t>
+              <a:t>STUDENT PRESENTATION • CI/CD WORKFLOW</a:t>
             </a:r>
           </a:p>
         </p:txBody>
@@ -7652,7 +7620,7 @@
               </a:defRPr>
             </a:pPr>
             <a:r>
-              <a:t>CI/CD Pipeline: GitHub Actions</a:t>
+              <a:t>CI/CD Pipeline with GitHub Actions</a:t>
             </a:r>
           </a:p>
         </p:txBody>
@@ -7688,7 +7656,7 @@
               </a:defRPr>
             </a:pPr>
             <a:r>
-              <a:t>Automated Quality Gates, Vulnerability Blocking, and Immutable Tagging</a:t>
+              <a:t>Automating code checks, test coverage, and security vulnerability scanning</a:t>
             </a:r>
           </a:p>
         </p:txBody>
@@ -7769,7 +7737,7 @@
               </a:defRPr>
             </a:pPr>
             <a:r>
-              <a:t>Gate 1: Code Quality &amp; Static Analysis</a:t>
+              <a:t>Step 1: Code Quality &amp; Linting</a:t>
             </a:r>
           </a:p>
         </p:txBody>
@@ -7808,7 +7776,7 @@
               </a:defRPr>
             </a:pPr>
             <a:r>
-              <a:t>• Ruff: Ultra-fast linting and code formatting checks across all backend Python modules.</a:t>
+              <a:t>• What it does: Runs Ruff for Python code formatting and Mypy for static type validation.</a:t>
             </a:r>
           </a:p>
           <a:p>
@@ -7824,7 +7792,7 @@
               </a:defRPr>
             </a:pPr>
             <a:r>
-              <a:t>• Mypy: Static type checking ensuring Pydantic and FastAPI schema integrity.</a:t>
+              <a:t>• Why it matters: Catches syntax errors, bad imports, and type mismatches before tests run.</a:t>
             </a:r>
           </a:p>
           <a:p>
@@ -7840,7 +7808,7 @@
               </a:defRPr>
             </a:pPr>
             <a:r>
-              <a:t>• ESLint: Static code analysis ensuring frontend React components follow strict standards.</a:t>
+              <a:t>• Frontend: Runs npm run lint to catch unused variables and component bugs.</a:t>
             </a:r>
           </a:p>
         </p:txBody>
@@ -7921,7 +7889,7 @@
               </a:defRPr>
             </a:pPr>
             <a:r>
-              <a:t>Gate 2: Automated Testing &amp; Coverage Gate</a:t>
+              <a:t>Step 2: Automated Tests &amp; Coverage Gate</a:t>
             </a:r>
           </a:p>
         </p:txBody>
@@ -7960,7 +7928,7 @@
               </a:defRPr>
             </a:pPr>
             <a:r>
-              <a:t>• Pytest: Executes 31 unit and integration tests against in-memory SQLite database.</a:t>
+              <a:t>• What it does: Executes 31 unit and integration tests using Pytest.</a:t>
             </a:r>
           </a:p>
           <a:p>
@@ -7976,7 +7944,7 @@
               </a:defRPr>
             </a:pPr>
             <a:r>
-              <a:t>• Coverage Gate: Pytest-cov enforces a hard 80% coverage threshold (currently achieving 91%).</a:t>
+              <a:t>• Coverage Gate: Pytest-cov enforces a strict 80% minimum coverage threshold.</a:t>
             </a:r>
           </a:p>
           <a:p>
@@ -7992,7 +7960,7 @@
               </a:defRPr>
             </a:pPr>
             <a:r>
-              <a:t>• Pipeline Failure: Any failing test or coverage drop below 80% instantly terminates the workflow.</a:t>
+              <a:t>• Current Result: 90.99% overall code coverage. If coverage falls below 80%, the build fails.</a:t>
             </a:r>
           </a:p>
         </p:txBody>
@@ -8073,7 +8041,7 @@
               </a:defRPr>
             </a:pPr>
             <a:r>
-              <a:t>Gate 3: Hardened Build &amp; Trivy Vulnerability Scan</a:t>
+              <a:t>Step 3: Build &amp; Security Scanning (Trivy)</a:t>
             </a:r>
           </a:p>
         </p:txBody>
@@ -8112,7 +8080,7 @@
               </a:defRPr>
             </a:pPr>
             <a:r>
-              <a:t>• Docker Buildx: Multi-stage builds compiling frontend assets and backend dependencies.</a:t>
+              <a:t>• What it does: Builds multi-stage Docker images and scans them with Trivy.</a:t>
             </a:r>
           </a:p>
           <a:p>
@@ -8128,7 +8096,7 @@
               </a:defRPr>
             </a:pPr>
             <a:r>
-              <a:t>• Trivy Scanner: Scans root filesystem and built images with exit-code: 1 on HIGH/CRITICAL CVEs.</a:t>
+              <a:t>• Security Gate: Fails the pipeline if any HIGH or CRITICAL CVEs are detected.</a:t>
             </a:r>
           </a:p>
           <a:p>
@@ -8144,7 +8112,7 @@
               </a:defRPr>
             </a:pPr>
             <a:r>
-              <a:t>• GHCR Publishing: Immutable tags using github.sha (e.g. ghcr.io/user/podiumhq-backend:f990516).</a:t>
+              <a:t>• Publishing: Successful builds are pushed to GHCR with immutable Git SHA tags, never :latest.</a:t>
             </a:r>
           </a:p>
         </p:txBody>
@@ -8180,7 +8148,7 @@
               </a:defRPr>
             </a:pPr>
             <a:r>
-              <a:t>PodiumHQ DevSecOps Capstone • GitOps, Automated Verification &amp; Observability</a:t>
+              <a:t>PodiumHQ DevSecOps Capstone Presentation • Verified Codebase &amp; Realistic Engineering</a:t>
             </a:r>
           </a:p>
         </p:txBody>
@@ -8324,7 +8292,7 @@
               </a:defRPr>
             </a:pPr>
             <a:r>
-              <a:t>MODULE CHECKPOINT • TERRAFORM IAC SPECIFICATION</a:t>
+              <a:t>STUDENT PRESENTATION • TERRAFORM IAC</a:t>
             </a:r>
           </a:p>
         </p:txBody>
@@ -8432,7 +8400,7 @@
               </a:defRPr>
             </a:pPr>
             <a:r>
-              <a:t>Modular, Reproducible Cloud Infrastructure Provisioning across 3 AZs</a:t>
+              <a:t>Writing code to provision cloud networks and Kubernetes instead of manual setup</a:t>
             </a:r>
           </a:p>
         </p:txBody>
@@ -8513,7 +8481,7 @@
               </a:defRPr>
             </a:pPr>
             <a:r>
-              <a:t>VPC &amp; Network Architecture (vpc.tf)</a:t>
+              <a:t>Network: AWS VPC (vpc.tf)</a:t>
             </a:r>
           </a:p>
         </p:txBody>
@@ -8552,7 +8520,7 @@
               </a:defRPr>
             </a:pPr>
             <a:r>
-              <a:t>• Region: AWS ap-south-1 (Mumbai) across 3 Availability Zones for fault tolerance.</a:t>
+              <a:t>• Spans 3 Availability Zones in AWS ap-south-1 (Mumbai) for reliability.</a:t>
             </a:r>
           </a:p>
           <a:p>
@@ -8568,7 +8536,7 @@
               </a:defRPr>
             </a:pPr>
             <a:r>
-              <a:t>• Subnet Layout: 3 public subnets (for Ingress/ALBs) and 3 private subnets (for EKS worker nodes).</a:t>
+              <a:t>• Creates 3 public subnets (for internet ingress) and 3 private subnets (for worker nodes).</a:t>
             </a:r>
           </a:p>
           <a:p>
@@ -8584,7 +8552,7 @@
               </a:defRPr>
             </a:pPr>
             <a:r>
-              <a:t>• Egress: Dedicated NAT Gateway in public subnet routing private outbound internet traffic.</a:t>
+              <a:t>• Includes a NAT Gateway so private worker nodes can safely pull container images.</a:t>
             </a:r>
           </a:p>
           <a:p>
@@ -8600,7 +8568,7 @@
               </a:defRPr>
             </a:pPr>
             <a:r>
-              <a:t>• Kubernetes Tags: Strict kubernetes.io/role/elb and internal-elb tags for AWS Load Balancer Controller.</a:t>
+              <a:t>• Tagged with kubernetes.io/role/elb so AWS can automatically manage load balancers.</a:t>
             </a:r>
           </a:p>
         </p:txBody>
@@ -8681,7 +8649,7 @@
               </a:defRPr>
             </a:pPr>
             <a:r>
-              <a:t>EKS Cluster &amp; Node Groups (eks.tf)</a:t>
+              <a:t>Compute: EKS Cluster (eks.tf &amp; addons.tf)</a:t>
             </a:r>
           </a:p>
         </p:txBody>
@@ -8720,7 +8688,7 @@
               </a:defRPr>
             </a:pPr>
             <a:r>
-              <a:t>• EKS Control Plane: Managed Kubernetes v1.30 control plane with private &amp; public API endpoints.</a:t>
+              <a:t>• Deploys a managed Kubernetes v1.30 control plane with managed node groups.</a:t>
             </a:r>
           </a:p>
           <a:p>
@@ -8736,7 +8704,7 @@
               </a:defRPr>
             </a:pPr>
             <a:r>
-              <a:t>• Managed Node Group: 2 to 4 t3.medium EC2 instances distributed across private subnets.</a:t>
+              <a:t>• Worker nodes: 2 to 4 t3.medium EC2 instances distributed across private subnets.</a:t>
             </a:r>
           </a:p>
           <a:p>
@@ -8752,7 +8720,7 @@
               </a:defRPr>
             </a:pPr>
             <a:r>
-              <a:t>• IAM Roles: Least-privilege roles for EKS Cluster, CNI, and ContainerRegistryReadOnly.</a:t>
+              <a:t>• Add-on 1: AWS EBS CSI driver—required so PostgreSQL can attach persistent disk volumes.</a:t>
             </a:r>
           </a:p>
           <a:p>
@@ -8768,7 +8736,7 @@
               </a:defRPr>
             </a:pPr>
             <a:r>
-              <a:t>• Add-ons (addons.tf): AWS EBS CSI driver (for gp3 volumes) and Kubernetes Metrics Server (for HPA).</a:t>
+              <a:t>• Add-on 2: Metrics Server—required so the Horizontal Pod Autoscaler can read CPU usage.</a:t>
             </a:r>
           </a:p>
         </p:txBody>
@@ -8849,7 +8817,7 @@
               </a:defRPr>
             </a:pPr>
             <a:r>
-              <a:t>Cost Safety &amp; Teardown Runbook</a:t>
+              <a:t>Honest Cloud Status &amp; Teardown Runbook</a:t>
             </a:r>
           </a:p>
         </p:txBody>
@@ -8888,7 +8856,7 @@
               </a:defRPr>
             </a:pPr>
             <a:r>
-              <a:t>• Reproducibility: Configured via terraform.tfvars.example with parameterized variables.</a:t>
+              <a:t>• Status: Terraform files are written, formatted, and validated with terraform validate.</a:t>
             </a:r>
           </a:p>
           <a:p>
@@ -8904,7 +8872,7 @@
               </a:defRPr>
             </a:pPr>
             <a:r>
-              <a:t>• Automated Teardown: Documented runbook in terraform/README.md for clean resource destruction.</a:t>
+              <a:t>• Cost Note: EKS and NAT Gateways cost ~$0.15/hour, so this was not left permanently running on AWS.</a:t>
             </a:r>
           </a:p>
           <a:p>
@@ -8920,7 +8888,7 @@
               </a:defRPr>
             </a:pPr>
             <a:r>
-              <a:t>• Zero-Leak Guarantee: PVCs and Ingresses uninstalled prior to terraform destroy to prevent dangling ALBs.</a:t>
+              <a:t>• Safety: Provided a complete terraform destroy runbook in terraform/README.md for clean teardown.</a:t>
             </a:r>
           </a:p>
         </p:txBody>
@@ -8956,7 +8924,7 @@
               </a:defRPr>
             </a:pPr>
             <a:r>
-              <a:t>PodiumHQ DevSecOps Capstone • GitOps, Automated Verification &amp; Observability</a:t>
+              <a:t>PodiumHQ DevSecOps Capstone Presentation • Verified Codebase &amp; Realistic Engineering</a:t>
             </a:r>
           </a:p>
         </p:txBody>
@@ -9100,7 +9068,7 @@
               </a:defRPr>
             </a:pPr>
             <a:r>
-              <a:t>MODULE CHECKPOINT • KUBERNETES &amp; HELM DEPLOYMENT</a:t>
+              <a:t>STUDENT PRESENTATION • KUBERNETES &amp; HELM</a:t>
             </a:r>
           </a:p>
         </p:txBody>
@@ -9172,7 +9140,7 @@
               </a:defRPr>
             </a:pPr>
             <a:r>
-              <a:t>Kubernetes Packaging: Helm &amp; Workloads</a:t>
+              <a:t>Kubernetes &amp; Helm: Packaging Workloads</a:t>
             </a:r>
           </a:p>
         </p:txBody>
@@ -9208,7 +9176,7 @@
               </a:defRPr>
             </a:pPr>
             <a:r>
-              <a:t>Declarative Packaging, Non-Root Workloads, and Migration Job Hooks</a:t>
+              <a:t>Managing application deployments, services, scaling, and database migrations</a:t>
             </a:r>
           </a:p>
         </p:txBody>
@@ -9289,7 +9257,7 @@
               </a:defRPr>
             </a:pPr>
             <a:r>
-              <a:t>Workload Declarations</a:t>
+              <a:t>Workloads &amp; High Availability</a:t>
             </a:r>
           </a:p>
         </p:txBody>
@@ -9328,7 +9296,7 @@
               </a:defRPr>
             </a:pPr>
             <a:r>
-              <a:t>• Backend Deployment: 2 replicas, rolling updates (maxSurge: 1, maxUnavailable: 0), liveness and readiness probes.</a:t>
+              <a:t>• Packaged as a Helm chart in helm/podiumhq with values-dev and values-prod.</a:t>
             </a:r>
           </a:p>
           <a:p>
@@ -9344,7 +9312,7 @@
               </a:defRPr>
             </a:pPr>
             <a:r>
-              <a:t>• Frontend Deployment: 2 replicas, unprivileged Nginx reverse-proxying API traffic to backend.</a:t>
+              <a:t>• Backend &amp; Frontend Deployments: 2 replicas each with RollingUpdate strategy.</a:t>
             </a:r>
           </a:p>
           <a:p>
@@ -9360,7 +9328,7 @@
               </a:defRPr>
             </a:pPr>
             <a:r>
-              <a:t>• PostgreSQL StatefulSet: 1 replica with gp3 StorageClass PersistentVolumeClaim (10Gi).</a:t>
+              <a:t>• PodDisruptionBudget (PDB): Guarantees at least 1 backend pod stays online during node updates.</a:t>
             </a:r>
           </a:p>
           <a:p>
@@ -9376,7 +9344,7 @@
               </a:defRPr>
             </a:pPr>
             <a:r>
-              <a:t>• PodDisruptionBudget (PDB): Guarantees at least 1 backend pod remains available during node maintenance.</a:t>
+              <a:t>• Horizontal Pod Autoscaler (HPA): Automatically scales backend from 2 to 6 pods when CPU &gt; 60%.</a:t>
             </a:r>
           </a:p>
         </p:txBody>
@@ -9457,7 +9425,7 @@
               </a:defRPr>
             </a:pPr>
             <a:r>
-              <a:t>SecurityContext &amp; Hardening</a:t>
+              <a:t>Container Security in Kubernetes</a:t>
             </a:r>
           </a:p>
         </p:txBody>
@@ -9496,7 +9464,7 @@
               </a:defRPr>
             </a:pPr>
             <a:r>
-              <a:t>• Backend Pods: runAsNonRoot: true, runAsUser: 10001, runAsGroup: 10001, drop ALL capabilities.</a:t>
+              <a:t>• Enforces securityContext on all pods: runAsNonRoot: true.</a:t>
             </a:r>
           </a:p>
           <a:p>
@@ -9512,7 +9480,7 @@
               </a:defRPr>
             </a:pPr>
             <a:r>
-              <a:t>• Frontend Pods: runAsNonRoot: true, runAsUser: 101, runAsGroup: 101, drop ALL capabilities.</a:t>
+              <a:t>• Backend runs as UID 10001; Frontend runs as Nginx UID 101.</a:t>
             </a:r>
           </a:p>
           <a:p>
@@ -9528,7 +9496,23 @@
               </a:defRPr>
             </a:pPr>
             <a:r>
-              <a:t>• Ingress Controller: Routes / to frontend and /api, /health, /ready, /metrics to backend service.</a:t>
+              <a:t>• Drops all Linux capabilities (capabilities: drop: [ALL]) to limit attack surface.</a:t>
+            </a:r>
+          </a:p>
+          <a:p>
+            <a:pPr>
+              <a:spcAft>
+                <a:spcPts val="800"/>
+              </a:spcAft>
+              <a:defRPr sz="1200">
+                <a:solidFill>
+                  <a:srgbClr val="F8FAFC"/>
+                </a:solidFill>
+                <a:latin typeface="Calibri"/>
+              </a:defRPr>
+            </a:pPr>
+            <a:r>
+              <a:t>• Ingress routes / to frontend, and /api, /health, /ready, /metrics to backend.</a:t>
             </a:r>
           </a:p>
         </p:txBody>
@@ -9609,7 +9593,7 @@
               </a:defRPr>
             </a:pPr>
             <a:r>
-              <a:t>Database Migration Hook (Race Prevention)</a:t>
+              <a:t>Database Migration Job Hook</a:t>
             </a:r>
           </a:p>
         </p:txBody>
@@ -9648,7 +9632,7 @@
               </a:defRPr>
             </a:pPr>
             <a:r>
-              <a:t>• Problem Solved: Multiple backend replicas starting simultaneously cause database migration lock races.</a:t>
+              <a:t>• The Problem: When 2+ backend pods boot at the same time, they race to run database migrations.</a:t>
             </a:r>
           </a:p>
           <a:p>
@@ -9664,7 +9648,7 @@
               </a:defRPr>
             </a:pPr>
             <a:r>
-              <a:t>• Helm Hook Job: migration-job.yaml runs 'alembic upgrade head' as a pre-install/pre-upgrade hook.</a:t>
+              <a:t>• The Solution: Created a Helm pre-upgrade/pre-install Job hook (migration-job.yaml).</a:t>
             </a:r>
           </a:p>
           <a:p>
@@ -9680,7 +9664,7 @@
               </a:defRPr>
             </a:pPr>
             <a:r>
-              <a:t>• App pods start with RUN_MIGRATIONS=false only AFTER the migration Job reports success.</a:t>
+              <a:t>• Alembic migrations run to completion first in an isolated job; application pods start only after it succeeds.</a:t>
             </a:r>
           </a:p>
         </p:txBody>
@@ -9716,7 +9700,7 @@
               </a:defRPr>
             </a:pPr>
             <a:r>
-              <a:t>PodiumHQ DevSecOps Capstone • GitOps, Automated Verification &amp; Observability</a:t>
+              <a:t>PodiumHQ DevSecOps Capstone Presentation • Verified Codebase &amp; Realistic Engineering</a:t>
             </a:r>
           </a:p>
         </p:txBody>
@@ -9860,7 +9844,7 @@
               </a:defRPr>
             </a:pPr>
             <a:r>
-              <a:t>MODULE CHECKPOINT • GITOPS CONTINUOUS DELIVERY</a:t>
+              <a:t>STUDENT PRESENTATION • GITOPS CONTINUOUS DELIVERY</a:t>
             </a:r>
           </a:p>
         </p:txBody>
@@ -9932,7 +9916,7 @@
               </a:defRPr>
             </a:pPr>
             <a:r>
-              <a:t>GitOps with ArgoCD</a:t>
+              <a:t>GitOps with ArgoCD: Declarative Delivery</a:t>
             </a:r>
           </a:p>
         </p:txBody>
@@ -9968,7 +9952,7 @@
               </a:defRPr>
             </a:pPr>
             <a:r>
-              <a:t>Continuous Reconciliation, Automated Syncing, and Self-Healing Drift Control</a:t>
+              <a:t>Using Git as the single source of truth for cluster state and self-healing</a:t>
             </a:r>
           </a:p>
         </p:txBody>
@@ -10049,7 +10033,7 @@
               </a:defRPr>
             </a:pPr>
             <a:r>
-              <a:t>ArgoCD Application Configuration</a:t>
+              <a:t>What is GitOps &amp; Why ArgoCD?</a:t>
             </a:r>
           </a:p>
         </p:txBody>
@@ -10088,7 +10072,7 @@
               </a:defRPr>
             </a:pPr>
             <a:r>
-              <a:t>• Manifest: argocd/application.yaml targeting namespace podiumhq with project: default.</a:t>
+              <a:t>• Concept: Instead of engineers running manual kubectl apply, Git holds the desired state.</a:t>
             </a:r>
           </a:p>
           <a:p>
@@ -10104,7 +10088,7 @@
               </a:defRPr>
             </a:pPr>
             <a:r>
-              <a:t>• Source: Watches this Git repository (path: helm/podiumhq, targetRevision: HEAD).</a:t>
+              <a:t>• ArgoCD controller runs inside the cluster and constantly compares live state against Git.</a:t>
             </a:r>
           </a:p>
           <a:p>
@@ -10120,7 +10104,7 @@
               </a:defRPr>
             </a:pPr>
             <a:r>
-              <a:t>• Environment Values: Uses values-prod.yaml for production cluster deployment.</a:t>
+              <a:t>• Configured in argocd/application.yaml watching the helm/podiumhq chart in this repo.</a:t>
             </a:r>
           </a:p>
         </p:txBody>
@@ -10201,7 +10185,7 @@
               </a:defRPr>
             </a:pPr>
             <a:r>
-              <a:t>Automated Sync &amp; Self-Healing</a:t>
+              <a:t>Automated Sync &amp; Pruning</a:t>
             </a:r>
           </a:p>
         </p:txBody>
@@ -10240,7 +10224,7 @@
               </a:defRPr>
             </a:pPr>
             <a:r>
-              <a:t>• Automated Sync: ArgoCD automatically detects new image tag commits and applies them without human intervention.</a:t>
+              <a:t>• Automated Sync: When CI updates the image tag in Git, ArgoCD automatically applies the change.</a:t>
             </a:r>
           </a:p>
           <a:p>
@@ -10256,7 +10240,7 @@
               </a:defRPr>
             </a:pPr>
             <a:r>
-              <a:t>• Self-Healing (selfHeal: true): If an engineer manually alters cluster state via kubectl, ArgoCD immediately reverts the drift.</a:t>
+              <a:t>• Automated Pruning (prune: true): Removes old deleted resources from the cluster automatically.</a:t>
             </a:r>
           </a:p>
           <a:p>
@@ -10272,7 +10256,7 @@
               </a:defRPr>
             </a:pPr>
             <a:r>
-              <a:t>• Pruning (prune: true): Deletes orphaned cluster resources when removed from Helm templates.</a:t>
+              <a:t>• Audit Trail: Every cluster change corresponds to a verifiable Git commit hash.</a:t>
             </a:r>
           </a:p>
         </p:txBody>
@@ -10353,7 +10337,7 @@
               </a:defRPr>
             </a:pPr>
             <a:r>
-              <a:t>Live Drift Demonstration (Viva Check)</a:t>
+              <a:t>Self-Healing Drift Demonstration</a:t>
             </a:r>
           </a:p>
         </p:txBody>
@@ -10392,7 +10376,7 @@
               </a:defRPr>
             </a:pPr>
             <a:r>
-              <a:t>• Step 1: Manually scale backend deployment: 'kubectl scale deployment podiumhq-backend --replicas=5'.</a:t>
+              <a:t>• What is drift?: When someone manually alters resources in the cluster using kubectl.</a:t>
             </a:r>
           </a:p>
           <a:p>
@@ -10408,7 +10392,7 @@
               </a:defRPr>
             </a:pPr>
             <a:r>
-              <a:t>• Step 2: ArgoCD detects state drift and marks application OutOfSync.</a:t>
+              <a:t>• Self-Healing (selfHeal: true): ArgoCD detects the discrepancy and immediately reverts it.</a:t>
             </a:r>
           </a:p>
           <a:p>
@@ -10424,7 +10408,7 @@
               </a:defRPr>
             </a:pPr>
             <a:r>
-              <a:t>• Step 3: Within seconds, ArgoCD self-heals the cluster back to the Git source of truth (2 replicas).</a:t>
+              <a:t>• Demo check: If I run 'kubectl scale deployment backend --replicas=5', ArgoCD forces it back to 2.</a:t>
             </a:r>
           </a:p>
         </p:txBody>
@@ -10460,7 +10444,7 @@
               </a:defRPr>
             </a:pPr>
             <a:r>
-              <a:t>PodiumHQ DevSecOps Capstone • GitOps, Automated Verification &amp; Observability</a:t>
+              <a:t>PodiumHQ DevSecOps Capstone Presentation • Verified Codebase &amp; Realistic Engineering</a:t>
             </a:r>
           </a:p>
         </p:txBody>
@@ -10604,7 +10588,7 @@
               </a:defRPr>
             </a:pPr>
             <a:r>
-              <a:t>MODULE CHECKPOINT • OBSERVABILITY &amp; MONITORING</a:t>
+              <a:t>STUDENT PRESENTATION • OBSERVABILITY &amp; METRICS</a:t>
             </a:r>
           </a:p>
         </p:txBody>
@@ -10712,7 +10696,7 @@
               </a:defRPr>
             </a:pPr>
             <a:r>
-              <a:t>Full-Stack System Metrics, Custom Domain Telemetry, and Alerting Rules</a:t>
+              <a:t>Monitoring system health, request traffic, and custom judging metrics</a:t>
             </a:r>
           </a:p>
         </p:txBody>
@@ -10793,7 +10777,7 @@
               </a:defRPr>
             </a:pPr>
             <a:r>
-              <a:t>Exposed Telemetry (/metrics)</a:t>
+              <a:t>System Metrics on /metrics</a:t>
             </a:r>
           </a:p>
         </p:txBody>
@@ -10832,7 +10816,7 @@
               </a:defRPr>
             </a:pPr>
             <a:r>
-              <a:t>• Standard Metrics: HTTP request counts, response status codes (2xx/4xx/5xx), and latency histograms.</a:t>
+              <a:t>• What it does: Backend exposes a Prometheus-format endpoint at /metrics.</a:t>
             </a:r>
           </a:p>
           <a:p>
@@ -10848,7 +10832,7 @@
               </a:defRPr>
             </a:pPr>
             <a:r>
-              <a:t>• Runtime Telemetry: Python garbage collection, memory usage, CPU seconds, and active file descriptors.</a:t>
+              <a:t>• HTTP Telemetry: Tracks total requests, response status codes (2xx, 4xx, 5xx), and p95 latency.</a:t>
             </a:r>
           </a:p>
           <a:p>
@@ -10864,7 +10848,7 @@
               </a:defRPr>
             </a:pPr>
             <a:r>
-              <a:t>• Instrumentation: Powered by prometheus-client and prometheus-fastapi-instrumentator.</a:t>
+              <a:t>• Runtime Telemetry: Tracks Python garbage collection, memory usage, CPU time, and open file descriptors.</a:t>
             </a:r>
           </a:p>
         </p:txBody>
@@ -10984,7 +10968,7 @@
               </a:defRPr>
             </a:pPr>
             <a:r>
-              <a:t>• podiumhq_scores_submitted_total: Counter tracking total judge scores submitted across rounds.</a:t>
+              <a:t>• podiumhq_scores_submitted_total: Counter tracking how many judge scores have been submitted.</a:t>
             </a:r>
           </a:p>
           <a:p>
@@ -11000,7 +10984,7 @@
               </a:defRPr>
             </a:pPr>
             <a:r>
-              <a:t>• podiumhq_teams_by_status: Gauge tracking team counts categorized by lifecycle status (ACTIVE, EVALUATED).</a:t>
+              <a:t>• podiumhq_teams_by_status: Gauge showing active vs evaluated teams in the hackathon.</a:t>
             </a:r>
           </a:p>
           <a:p>
@@ -11016,7 +11000,7 @@
               </a:defRPr>
             </a:pPr>
             <a:r>
-              <a:t>• podiumhq_leaderboard_requests_total: Counter tracking traffic to the live standings endpoint.</a:t>
+              <a:t>• podiumhq_leaderboard_requests_total: Counter tracking how often the leaderboard is viewed.</a:t>
             </a:r>
           </a:p>
         </p:txBody>
@@ -11097,7 +11081,7 @@
               </a:defRPr>
             </a:pPr>
             <a:r>
-              <a:t>Grafana Dashboard &amp; PrometheusRules</a:t>
+              <a:t>Grafana Dashboard &amp; Alert Rules</a:t>
             </a:r>
           </a:p>
         </p:txBody>
@@ -11136,7 +11120,7 @@
               </a:defRPr>
             </a:pPr>
             <a:r>
-              <a:t>• Grafana JSON (monitoring/grafana-dashboard.json): 5+ real-time panels tracking RPS, p95 latency, errors, and domain stats.</a:t>
+              <a:t>• Grafana JSON (monitoring/grafana-dashboard.json): 5 panels showing RPS, p95 latency, 5xx errors, and scores.</a:t>
             </a:r>
           </a:p>
           <a:p>
@@ -11152,7 +11136,7 @@
               </a:defRPr>
             </a:pPr>
             <a:r>
-              <a:t>• PrometheusRule (monitoring/alerts.yaml): Automated alerts for High Error Rate (&gt;1% 5xx) and Backend Target Down.</a:t>
+              <a:t>• PrometheusRule (monitoring/alerts.yaml): Triggers an alert if 5xx errors exceed 1% for 2 minutes.</a:t>
             </a:r>
           </a:p>
           <a:p>
@@ -11168,7 +11152,7 @@
               </a:defRPr>
             </a:pPr>
             <a:r>
-              <a:t>• ServiceMonitor: Scrapes backend service every 15s via Prometheus Operator.</a:t>
+              <a:t>• Target Down Alert: Alerts immediately if the backend service stops responding.</a:t>
             </a:r>
           </a:p>
         </p:txBody>
@@ -11204,7 +11188,7 @@
               </a:defRPr>
             </a:pPr>
             <a:r>
-              <a:t>PodiumHQ DevSecOps Capstone • GitOps, Automated Verification &amp; Observability</a:t>
+              <a:t>PodiumHQ DevSecOps Capstone Presentation • Verified Codebase &amp; Realistic Engineering</a:t>
             </a:r>
           </a:p>
         </p:txBody>
@@ -11348,7 +11332,7 @@
               </a:defRPr>
             </a:pPr>
             <a:r>
-              <a:t>MODULE CHECKPOINT • VERIFICATION &amp; ENGINEERING CHALLENGES</a:t>
+              <a:t>STUDENT PRESENTATION • TESTING &amp; REAL DEBUGGING</a:t>
             </a:r>
           </a:p>
         </p:txBody>
@@ -11420,7 +11404,7 @@
               </a:defRPr>
             </a:pPr>
             <a:r>
-              <a:t>Testing, Security, &amp; Real Challenges</a:t>
+              <a:t>Testing, Security &amp; Real Debugging Challenges</a:t>
             </a:r>
           </a:p>
         </p:txBody>
@@ -11456,7 +11440,7 @@
               </a:defRPr>
             </a:pPr>
             <a:r>
-              <a:t>91% Test Coverage, Container Non-Root Verification, and Practical Bug Fixes</a:t>
+              <a:t>Verified test coverage, non-root checks, and authentic bugs I ran into and fixed</a:t>
             </a:r>
           </a:p>
         </p:txBody>
@@ -11537,7 +11521,7 @@
               </a:defRPr>
             </a:pPr>
             <a:r>
-              <a:t>Automated Testing Verification</a:t>
+              <a:t>Verified Test &amp; Security Results</a:t>
             </a:r>
           </a:p>
         </p:txBody>
@@ -11576,7 +11560,7 @@
               </a:defRPr>
             </a:pPr>
             <a:r>
-              <a:t>• Pytest Results: 31 passed in 1.32s with 90.99% overall code coverage (target: &gt;=80%).</a:t>
+              <a:t>• Pytest Results: 31 tests passed in 1.32 seconds with 90.99% statement coverage.</a:t>
             </a:r>
           </a:p>
           <a:p>
@@ -11592,7 +11576,7 @@
               </a:defRPr>
             </a:pPr>
             <a:r>
-              <a:t>• Test Isolation: SQLite with StaticPool ensures zero interference between test runs.</a:t>
+              <a:t>• Test Isolation: Runs against an in-memory SQLite database so tests never pollute real data.</a:t>
             </a:r>
           </a:p>
           <a:p>
@@ -11608,7 +11592,7 @@
               </a:defRPr>
             </a:pPr>
             <a:r>
-              <a:t>• Business Logic Verified: Tie-breaking, duplicate score rejection, and round lifecycle locks.</a:t>
+              <a:t>• Verified Non-Root: Ran 'docker compose exec backend id' -&gt; uid=10001(appuser) and frontend -&gt; uid=101(nginx).</a:t>
             </a:r>
           </a:p>
         </p:txBody>
@@ -11683,13 +11667,13 @@
             <a:pPr>
               <a:defRPr sz="1400" b="1">
                 <a:solidFill>
-                  <a:srgbClr val="38BDF8"/>
+                  <a:srgbClr val="F59E0B"/>
                 </a:solidFill>
                 <a:latin typeface="Arial"/>
               </a:defRPr>
             </a:pPr>
             <a:r>
-              <a:t>Container Security Verification</a:t>
+              <a:t>Real Bug 1: In-Container Pytest Permission Crash</a:t>
             </a:r>
           </a:p>
         </p:txBody>
@@ -11728,7 +11712,7 @@
               </a:defRPr>
             </a:pPr>
             <a:r>
-              <a:t>• Backend: Verified non-root execution via 'docker compose exec backend id' -&gt; uid=10001(appuser).</a:t>
+              <a:t>• The Problem: Running pytest inside the backend container crashed with sqlite3.OperationalError.</a:t>
             </a:r>
           </a:p>
           <a:p>
@@ -11744,7 +11728,7 @@
               </a:defRPr>
             </a:pPr>
             <a:r>
-              <a:t>• Frontend: Verified unprivileged execution via 'docker compose exec frontend id' -&gt; uid=101(nginx).</a:t>
+              <a:t>• Root Cause: Working directory /app was created by Docker as root; appuser couldn't write the .coverage file.</a:t>
             </a:r>
           </a:p>
           <a:p>
@@ -11760,7 +11744,7 @@
               </a:defRPr>
             </a:pPr>
             <a:r>
-              <a:t>• Secret Scanning: Gitleaks scan confirmed zero committed credentials or API keys in Git history.</a:t>
+              <a:t>• The Fix: Added explicit 'RUN chown -R appuser:appgroup /app' in the Dockerfile.</a:t>
             </a:r>
           </a:p>
         </p:txBody>
@@ -11835,13 +11819,13 @@
             <a:pPr>
               <a:defRPr sz="1400" b="1">
                 <a:solidFill>
-                  <a:srgbClr val="F59E0B"/>
+                  <a:srgbClr val="38BDF8"/>
                 </a:solidFill>
                 <a:latin typeface="Arial"/>
               </a:defRPr>
             </a:pPr>
             <a:r>
-              <a:t>Real Implementation Challenges Solved</a:t>
+              <a:t>Real Bug 2: Nginx IPv6 Healthcheck Failure</a:t>
             </a:r>
           </a:p>
         </p:txBody>
@@ -11880,7 +11864,7 @@
               </a:defRPr>
             </a:pPr>
             <a:r>
-              <a:t>• Challenge 1: In-container SQLite coverage database was blocked because /app was owned by root. Fixed by chowning /app to appuser.</a:t>
+              <a:t>• The Problem: Docker Compose reported the frontend container as 'unhealthy' even though web pages loaded.</a:t>
             </a:r>
           </a:p>
           <a:p>
@@ -11896,7 +11880,7 @@
               </a:defRPr>
             </a:pPr>
             <a:r>
-              <a:t>• Challenge 2: Frontend healthcheck failed with connection refused because BusyBox wget resolved localhost to IPv6 ::1. Fixed by adding listen [::]:8080.</a:t>
+              <a:t>• Root Cause: BusyBox wget resolved localhost to IPv6 ::1, but Nginx was only listening on IPv4 8080.</a:t>
             </a:r>
           </a:p>
           <a:p>
@@ -11912,7 +11896,7 @@
               </a:defRPr>
             </a:pPr>
             <a:r>
-              <a:t>• Challenge 3: Test dependencies were excluded by .dockerignore. Fixed by selectively including tests for in-container validation.</a:t>
+              <a:t>• The Fix: Added 'listen [::]:8080 default_server;' to the Nginx template and updated probe to 127.0.0.1.</a:t>
             </a:r>
           </a:p>
         </p:txBody>
@@ -11948,7 +11932,7 @@
               </a:defRPr>
             </a:pPr>
             <a:r>
-              <a:t>PodiumHQ DevSecOps Capstone • GitOps, Automated Verification &amp; Observability</a:t>
+              <a:t>PodiumHQ DevSecOps Capstone Presentation • Verified Codebase &amp; Realistic Engineering</a:t>
             </a:r>
           </a:p>
         </p:txBody>

</xml_diff>